<commit_message>
Adding first part of Lab H
</commit_message>
<xml_diff>
--- a/docs/chapters/week5/images.pptx
+++ b/docs/chapters/week5/images.pptx
@@ -9,6 +9,8 @@
     <p:sldId id="257" r:id="rId3"/>
     <p:sldId id="258" r:id="rId4"/>
     <p:sldId id="259" r:id="rId5"/>
+    <p:sldId id="260" r:id="rId6"/>
+    <p:sldId id="261" r:id="rId7"/>
   </p:sldIdLst>
   <p:sldSz cx="12192000" cy="6858000"/>
   <p:notesSz cx="6858000" cy="9144000"/>
@@ -118,7 +120,7 @@
 <file path=ppt/revisionInfo.xml><?xml version="1.0" encoding="utf-8"?>
 <p1510:revInfo xmlns:a="http://schemas.openxmlformats.org/drawingml/2006/main" xmlns:r="http://schemas.openxmlformats.org/officeDocument/2006/relationships" xmlns:p1510="http://schemas.microsoft.com/office/powerpoint/2015/10/main">
   <p1510:revLst>
-    <p1510:client id="{101CB27A-723E-4A06-93BC-310093EB70E2}" v="6" dt="2026-01-10T16:42:32.476"/>
+    <p1510:client id="{101CB27A-723E-4A06-93BC-310093EB70E2}" v="11" dt="2026-01-21T16:57:28.216"/>
   </p1510:revLst>
 </p1510:revInfo>
 </file>
@@ -128,7 +130,7 @@
   <pc:docChgLst>
     <pc:chgData name="Alex Casson" userId="53cffa54-f866-4b4c-8e51-0383f28edfe1" providerId="ADAL" clId="{6CFC2141-1B0A-45D5-9B60-96DCD45AC834}"/>
     <pc:docChg chg="undo custSel addSld modSld">
-      <pc:chgData name="Alex Casson" userId="53cffa54-f866-4b4c-8e51-0383f28edfe1" providerId="ADAL" clId="{6CFC2141-1B0A-45D5-9B60-96DCD45AC834}" dt="2026-01-10T16:42:40.636" v="39" actId="14100"/>
+      <pc:chgData name="Alex Casson" userId="53cffa54-f866-4b4c-8e51-0383f28edfe1" providerId="ADAL" clId="{6CFC2141-1B0A-45D5-9B60-96DCD45AC834}" dt="2026-01-21T18:23:23.208" v="86" actId="22"/>
       <pc:docMkLst>
         <pc:docMk/>
       </pc:docMkLst>
@@ -138,22 +140,6 @@
           <pc:docMk/>
           <pc:sldMk cId="2733535654" sldId="256"/>
         </pc:sldMkLst>
-        <pc:spChg chg="del">
-          <ac:chgData name="Alex Casson" userId="53cffa54-f866-4b4c-8e51-0383f28edfe1" providerId="ADAL" clId="{6CFC2141-1B0A-45D5-9B60-96DCD45AC834}" dt="2026-01-09T20:39:18.089" v="2" actId="478"/>
-          <ac:spMkLst>
-            <pc:docMk/>
-            <pc:sldMk cId="2733535654" sldId="256"/>
-            <ac:spMk id="2" creationId="{0132DF44-A8E2-827F-A4EB-A90BCC6B7988}"/>
-          </ac:spMkLst>
-        </pc:spChg>
-        <pc:spChg chg="del">
-          <ac:chgData name="Alex Casson" userId="53cffa54-f866-4b4c-8e51-0383f28edfe1" providerId="ADAL" clId="{6CFC2141-1B0A-45D5-9B60-96DCD45AC834}" dt="2026-01-09T20:39:17.531" v="1" actId="478"/>
-          <ac:spMkLst>
-            <pc:docMk/>
-            <pc:sldMk cId="2733535654" sldId="256"/>
-            <ac:spMk id="3" creationId="{9A3E7B4A-DB8B-5EA0-27C5-43DEF6B156D4}"/>
-          </ac:spMkLst>
-        </pc:spChg>
         <pc:spChg chg="add mod">
           <ac:chgData name="Alex Casson" userId="53cffa54-f866-4b4c-8e51-0383f28edfe1" providerId="ADAL" clId="{6CFC2141-1B0A-45D5-9B60-96DCD45AC834}" dt="2026-01-09T20:39:36.493" v="9" actId="14100"/>
           <ac:spMkLst>
@@ -177,22 +163,6 @@
           <pc:docMk/>
           <pc:sldMk cId="666755099" sldId="257"/>
         </pc:sldMkLst>
-        <pc:spChg chg="del">
-          <ac:chgData name="Alex Casson" userId="53cffa54-f866-4b4c-8e51-0383f28edfe1" providerId="ADAL" clId="{6CFC2141-1B0A-45D5-9B60-96DCD45AC834}" dt="2026-01-09T20:42:30.827" v="11" actId="478"/>
-          <ac:spMkLst>
-            <pc:docMk/>
-            <pc:sldMk cId="666755099" sldId="257"/>
-            <ac:spMk id="2" creationId="{0BD0DE1D-64B8-A32A-3C3E-59396A57E921}"/>
-          </ac:spMkLst>
-        </pc:spChg>
-        <pc:spChg chg="del">
-          <ac:chgData name="Alex Casson" userId="53cffa54-f866-4b4c-8e51-0383f28edfe1" providerId="ADAL" clId="{6CFC2141-1B0A-45D5-9B60-96DCD45AC834}" dt="2026-01-09T20:42:32.264" v="12" actId="478"/>
-          <ac:spMkLst>
-            <pc:docMk/>
-            <pc:sldMk cId="666755099" sldId="257"/>
-            <ac:spMk id="3" creationId="{D8D7E337-8AB1-06C7-0B94-92DE5859A8E1}"/>
-          </ac:spMkLst>
-        </pc:spChg>
         <pc:spChg chg="add mod">
           <ac:chgData name="Alex Casson" userId="53cffa54-f866-4b4c-8e51-0383f28edfe1" providerId="ADAL" clId="{6CFC2141-1B0A-45D5-9B60-96DCD45AC834}" dt="2026-01-09T20:42:40.150" v="16"/>
           <ac:spMkLst>
@@ -216,22 +186,6 @@
           <pc:docMk/>
           <pc:sldMk cId="1575840529" sldId="258"/>
         </pc:sldMkLst>
-        <pc:spChg chg="del">
-          <ac:chgData name="Alex Casson" userId="53cffa54-f866-4b4c-8e51-0383f28edfe1" providerId="ADAL" clId="{6CFC2141-1B0A-45D5-9B60-96DCD45AC834}" dt="2026-01-10T15:50:30.350" v="18" actId="478"/>
-          <ac:spMkLst>
-            <pc:docMk/>
-            <pc:sldMk cId="1575840529" sldId="258"/>
-            <ac:spMk id="2" creationId="{9CA8A168-BBA5-55A5-3F79-0B8BC342AF16}"/>
-          </ac:spMkLst>
-        </pc:spChg>
-        <pc:spChg chg="del">
-          <ac:chgData name="Alex Casson" userId="53cffa54-f866-4b4c-8e51-0383f28edfe1" providerId="ADAL" clId="{6CFC2141-1B0A-45D5-9B60-96DCD45AC834}" dt="2026-01-10T15:50:32.450" v="19" actId="478"/>
-          <ac:spMkLst>
-            <pc:docMk/>
-            <pc:sldMk cId="1575840529" sldId="258"/>
-            <ac:spMk id="3" creationId="{2F481B27-7A73-F35B-FBA3-46C2252B9D93}"/>
-          </ac:spMkLst>
-        </pc:spChg>
         <pc:spChg chg="add mod">
           <ac:chgData name="Alex Casson" userId="53cffa54-f866-4b4c-8e51-0383f28edfe1" providerId="ADAL" clId="{6CFC2141-1B0A-45D5-9B60-96DCD45AC834}" dt="2026-01-10T15:50:53.296" v="25" actId="14100"/>
           <ac:spMkLst>
@@ -255,22 +209,6 @@
           <pc:docMk/>
           <pc:sldMk cId="342545915" sldId="259"/>
         </pc:sldMkLst>
-        <pc:spChg chg="del">
-          <ac:chgData name="Alex Casson" userId="53cffa54-f866-4b4c-8e51-0383f28edfe1" providerId="ADAL" clId="{6CFC2141-1B0A-45D5-9B60-96DCD45AC834}" dt="2026-01-10T16:22:46.081" v="27" actId="478"/>
-          <ac:spMkLst>
-            <pc:docMk/>
-            <pc:sldMk cId="342545915" sldId="259"/>
-            <ac:spMk id="2" creationId="{D8B1C41F-26FD-B241-6D54-17679A22C274}"/>
-          </ac:spMkLst>
-        </pc:spChg>
-        <pc:spChg chg="del">
-          <ac:chgData name="Alex Casson" userId="53cffa54-f866-4b4c-8e51-0383f28edfe1" providerId="ADAL" clId="{6CFC2141-1B0A-45D5-9B60-96DCD45AC834}" dt="2026-01-10T16:22:47.306" v="28" actId="478"/>
-          <ac:spMkLst>
-            <pc:docMk/>
-            <pc:sldMk cId="342545915" sldId="259"/>
-            <ac:spMk id="3" creationId="{8CAF1337-D2FE-50EC-799F-902496C6FD45}"/>
-          </ac:spMkLst>
-        </pc:spChg>
         <pc:spChg chg="add mod">
           <ac:chgData name="Alex Casson" userId="53cffa54-f866-4b4c-8e51-0383f28edfe1" providerId="ADAL" clId="{6CFC2141-1B0A-45D5-9B60-96DCD45AC834}" dt="2026-01-10T16:42:20.519" v="33" actId="14100"/>
           <ac:spMkLst>
@@ -301,6 +239,108 @@
             <pc:docMk/>
             <pc:sldMk cId="342545915" sldId="259"/>
             <ac:picMk id="5" creationId="{FB18C9FC-6D7B-6DA6-C90E-D5FC254EA71E}"/>
+          </ac:picMkLst>
+        </pc:picChg>
+      </pc:sldChg>
+      <pc:sldChg chg="addSp delSp modSp new mod">
+        <pc:chgData name="Alex Casson" userId="53cffa54-f866-4b4c-8e51-0383f28edfe1" providerId="ADAL" clId="{6CFC2141-1B0A-45D5-9B60-96DCD45AC834}" dt="2026-01-21T16:57:36.160" v="82" actId="1076"/>
+        <pc:sldMkLst>
+          <pc:docMk/>
+          <pc:sldMk cId="3767502288" sldId="260"/>
+        </pc:sldMkLst>
+        <pc:spChg chg="del">
+          <ac:chgData name="Alex Casson" userId="53cffa54-f866-4b4c-8e51-0383f28edfe1" providerId="ADAL" clId="{6CFC2141-1B0A-45D5-9B60-96DCD45AC834}" dt="2026-01-21T16:56:07.151" v="42" actId="478"/>
+          <ac:spMkLst>
+            <pc:docMk/>
+            <pc:sldMk cId="3767502288" sldId="260"/>
+            <ac:spMk id="2" creationId="{049277C3-C95F-357A-A0EA-14345F44701B}"/>
+          </ac:spMkLst>
+        </pc:spChg>
+        <pc:spChg chg="del">
+          <ac:chgData name="Alex Casson" userId="53cffa54-f866-4b4c-8e51-0383f28edfe1" providerId="ADAL" clId="{6CFC2141-1B0A-45D5-9B60-96DCD45AC834}" dt="2026-01-21T16:56:06.595" v="41" actId="478"/>
+          <ac:spMkLst>
+            <pc:docMk/>
+            <pc:sldMk cId="3767502288" sldId="260"/>
+            <ac:spMk id="3" creationId="{E6F0D501-AD9E-09B1-9E0A-85E972B90E1F}"/>
+          </ac:spMkLst>
+        </pc:spChg>
+        <pc:spChg chg="add mod">
+          <ac:chgData name="Alex Casson" userId="53cffa54-f866-4b4c-8e51-0383f28edfe1" providerId="ADAL" clId="{6CFC2141-1B0A-45D5-9B60-96DCD45AC834}" dt="2026-01-21T16:56:23.009" v="46" actId="14100"/>
+          <ac:spMkLst>
+            <pc:docMk/>
+            <pc:sldMk cId="3767502288" sldId="260"/>
+            <ac:spMk id="6" creationId="{59967B01-22FE-2698-685D-55AA29DC3E35}"/>
+          </ac:spMkLst>
+        </pc:spChg>
+        <pc:spChg chg="add mod">
+          <ac:chgData name="Alex Casson" userId="53cffa54-f866-4b4c-8e51-0383f28edfe1" providerId="ADAL" clId="{6CFC2141-1B0A-45D5-9B60-96DCD45AC834}" dt="2026-01-21T16:56:38.258" v="49" actId="14100"/>
+          <ac:spMkLst>
+            <pc:docMk/>
+            <pc:sldMk cId="3767502288" sldId="260"/>
+            <ac:spMk id="7" creationId="{1A881A6B-57B6-4E6C-F1AD-97099994B462}"/>
+          </ac:spMkLst>
+        </pc:spChg>
+        <pc:spChg chg="add del mod">
+          <ac:chgData name="Alex Casson" userId="53cffa54-f866-4b4c-8e51-0383f28edfe1" providerId="ADAL" clId="{6CFC2141-1B0A-45D5-9B60-96DCD45AC834}" dt="2026-01-21T16:56:53.200" v="57" actId="478"/>
+          <ac:spMkLst>
+            <pc:docMk/>
+            <pc:sldMk cId="3767502288" sldId="260"/>
+            <ac:spMk id="8" creationId="{7CD1AB2C-7EFC-F1BF-2267-A88210BD303B}"/>
+          </ac:spMkLst>
+        </pc:spChg>
+        <pc:spChg chg="add mod">
+          <ac:chgData name="Alex Casson" userId="53cffa54-f866-4b4c-8e51-0383f28edfe1" providerId="ADAL" clId="{6CFC2141-1B0A-45D5-9B60-96DCD45AC834}" dt="2026-01-21T16:57:26.066" v="66" actId="1076"/>
+          <ac:spMkLst>
+            <pc:docMk/>
+            <pc:sldMk cId="3767502288" sldId="260"/>
+            <ac:spMk id="9" creationId="{A49EB342-8F8C-AEAE-B40A-A55BA3E5E9EA}"/>
+          </ac:spMkLst>
+        </pc:spChg>
+        <pc:spChg chg="add mod">
+          <ac:chgData name="Alex Casson" userId="53cffa54-f866-4b4c-8e51-0383f28edfe1" providerId="ADAL" clId="{6CFC2141-1B0A-45D5-9B60-96DCD45AC834}" dt="2026-01-21T16:57:36.160" v="82" actId="1076"/>
+          <ac:spMkLst>
+            <pc:docMk/>
+            <pc:sldMk cId="3767502288" sldId="260"/>
+            <ac:spMk id="10" creationId="{967AD69A-9D53-A598-FF9B-8A73E4FF61E7}"/>
+          </ac:spMkLst>
+        </pc:spChg>
+        <pc:picChg chg="add">
+          <ac:chgData name="Alex Casson" userId="53cffa54-f866-4b4c-8e51-0383f28edfe1" providerId="ADAL" clId="{6CFC2141-1B0A-45D5-9B60-96DCD45AC834}" dt="2026-01-21T16:56:08.720" v="43" actId="22"/>
+          <ac:picMkLst>
+            <pc:docMk/>
+            <pc:sldMk cId="3767502288" sldId="260"/>
+            <ac:picMk id="5" creationId="{583A83E4-BFA8-74A6-C8A3-14F85F5380BA}"/>
+          </ac:picMkLst>
+        </pc:picChg>
+      </pc:sldChg>
+      <pc:sldChg chg="addSp delSp new mod">
+        <pc:chgData name="Alex Casson" userId="53cffa54-f866-4b4c-8e51-0383f28edfe1" providerId="ADAL" clId="{6CFC2141-1B0A-45D5-9B60-96DCD45AC834}" dt="2026-01-21T18:23:23.208" v="86" actId="22"/>
+        <pc:sldMkLst>
+          <pc:docMk/>
+          <pc:sldMk cId="306873889" sldId="261"/>
+        </pc:sldMkLst>
+        <pc:spChg chg="del">
+          <ac:chgData name="Alex Casson" userId="53cffa54-f866-4b4c-8e51-0383f28edfe1" providerId="ADAL" clId="{6CFC2141-1B0A-45D5-9B60-96DCD45AC834}" dt="2026-01-21T18:23:21.373" v="84" actId="478"/>
+          <ac:spMkLst>
+            <pc:docMk/>
+            <pc:sldMk cId="306873889" sldId="261"/>
+            <ac:spMk id="2" creationId="{38B6C467-5C71-BB33-2600-6BBC9A8B28B1}"/>
+          </ac:spMkLst>
+        </pc:spChg>
+        <pc:spChg chg="del">
+          <ac:chgData name="Alex Casson" userId="53cffa54-f866-4b4c-8e51-0383f28edfe1" providerId="ADAL" clId="{6CFC2141-1B0A-45D5-9B60-96DCD45AC834}" dt="2026-01-21T18:23:22.149" v="85" actId="478"/>
+          <ac:spMkLst>
+            <pc:docMk/>
+            <pc:sldMk cId="306873889" sldId="261"/>
+            <ac:spMk id="3" creationId="{5460B31B-9425-116B-F823-A351623C013F}"/>
+          </ac:spMkLst>
+        </pc:spChg>
+        <pc:picChg chg="add">
+          <ac:chgData name="Alex Casson" userId="53cffa54-f866-4b4c-8e51-0383f28edfe1" providerId="ADAL" clId="{6CFC2141-1B0A-45D5-9B60-96DCD45AC834}" dt="2026-01-21T18:23:23.208" v="86" actId="22"/>
+          <ac:picMkLst>
+            <pc:docMk/>
+            <pc:sldMk cId="306873889" sldId="261"/>
+            <ac:picMk id="5" creationId="{F30A9EA9-DECB-E096-E169-D050C1C41844}"/>
           </ac:picMkLst>
         </pc:picChg>
       </pc:sldChg>
@@ -1337,6 +1377,310 @@
 </p:sld>
 </file>
 
+<file path=ppt/slides/slide5.xml><?xml version="1.0" encoding="utf-8"?>
+<p:sld xmlns:a="http://schemas.openxmlformats.org/drawingml/2006/main" xmlns:r="http://schemas.openxmlformats.org/officeDocument/2006/relationships" xmlns:p="http://schemas.openxmlformats.org/presentationml/2006/main">
+  <p:cSld>
+    <p:spTree>
+      <p:nvGrpSpPr>
+        <p:cNvPr id="1" name=""/>
+        <p:cNvGrpSpPr/>
+        <p:nvPr/>
+      </p:nvGrpSpPr>
+      <p:grpSpPr>
+        <a:xfrm>
+          <a:off x="0" y="0"/>
+          <a:ext cx="0" cy="0"/>
+          <a:chOff x="0" y="0"/>
+          <a:chExt cx="0" cy="0"/>
+        </a:xfrm>
+      </p:grpSpPr>
+      <p:pic>
+        <p:nvPicPr>
+          <p:cNvPr id="5" name="Picture 4">
+            <a:extLst>
+              <a:ext uri="{FF2B5EF4-FFF2-40B4-BE49-F238E27FC236}">
+                <a16:creationId xmlns:a16="http://schemas.microsoft.com/office/drawing/2014/main" id="{583A83E4-BFA8-74A6-C8A3-14F85F5380BA}"/>
+              </a:ext>
+            </a:extLst>
+          </p:cNvPr>
+          <p:cNvPicPr>
+            <a:picLocks noChangeAspect="1"/>
+          </p:cNvPicPr>
+          <p:nvPr/>
+        </p:nvPicPr>
+        <p:blipFill>
+          <a:blip r:embed="rId2"/>
+          <a:stretch>
+            <a:fillRect/>
+          </a:stretch>
+        </p:blipFill>
+        <p:spPr>
+          <a:xfrm>
+            <a:off x="967884" y="0"/>
+            <a:ext cx="10256231" cy="6858000"/>
+          </a:xfrm>
+          <a:prstGeom prst="rect">
+            <a:avLst/>
+          </a:prstGeom>
+        </p:spPr>
+      </p:pic>
+      <p:sp>
+        <p:nvSpPr>
+          <p:cNvPr id="6" name="Rectangle 5">
+            <a:extLst>
+              <a:ext uri="{FF2B5EF4-FFF2-40B4-BE49-F238E27FC236}">
+                <a16:creationId xmlns:a16="http://schemas.microsoft.com/office/drawing/2014/main" id="{59967B01-22FE-2698-685D-55AA29DC3E35}"/>
+              </a:ext>
+            </a:extLst>
+          </p:cNvPr>
+          <p:cNvSpPr/>
+          <p:nvPr/>
+        </p:nvSpPr>
+        <p:spPr>
+          <a:xfrm>
+            <a:off x="4094329" y="4406452"/>
+            <a:ext cx="1213478" cy="179836"/>
+          </a:xfrm>
+          <a:prstGeom prst="rect">
+            <a:avLst/>
+          </a:prstGeom>
+          <a:noFill/>
+          <a:ln w="28575">
+            <a:solidFill>
+              <a:srgbClr val="C00000"/>
+            </a:solidFill>
+          </a:ln>
+        </p:spPr>
+        <p:style>
+          <a:lnRef idx="2">
+            <a:schemeClr val="accent1">
+              <a:shade val="15000"/>
+            </a:schemeClr>
+          </a:lnRef>
+          <a:fillRef idx="1">
+            <a:schemeClr val="accent1"/>
+          </a:fillRef>
+          <a:effectRef idx="0">
+            <a:schemeClr val="accent1"/>
+          </a:effectRef>
+          <a:fontRef idx="minor">
+            <a:schemeClr val="lt1"/>
+          </a:fontRef>
+        </p:style>
+        <p:txBody>
+          <a:bodyPr rtlCol="0" anchor="ctr"/>
+          <a:lstStyle/>
+          <a:p>
+            <a:pPr algn="ctr"/>
+            <a:endParaRPr lang="en-GB"/>
+          </a:p>
+        </p:txBody>
+      </p:sp>
+      <p:sp>
+        <p:nvSpPr>
+          <p:cNvPr id="7" name="Rectangle 6">
+            <a:extLst>
+              <a:ext uri="{FF2B5EF4-FFF2-40B4-BE49-F238E27FC236}">
+                <a16:creationId xmlns:a16="http://schemas.microsoft.com/office/drawing/2014/main" id="{1A881A6B-57B6-4E6C-F1AD-97099994B462}"/>
+              </a:ext>
+            </a:extLst>
+          </p:cNvPr>
+          <p:cNvSpPr/>
+          <p:nvPr/>
+        </p:nvSpPr>
+        <p:spPr>
+          <a:xfrm>
+            <a:off x="4094329" y="4586288"/>
+            <a:ext cx="5092534" cy="1064418"/>
+          </a:xfrm>
+          <a:prstGeom prst="rect">
+            <a:avLst/>
+          </a:prstGeom>
+          <a:noFill/>
+          <a:ln w="28575">
+            <a:solidFill>
+              <a:srgbClr val="C00000"/>
+            </a:solidFill>
+          </a:ln>
+        </p:spPr>
+        <p:style>
+          <a:lnRef idx="2">
+            <a:schemeClr val="accent1">
+              <a:shade val="15000"/>
+            </a:schemeClr>
+          </a:lnRef>
+          <a:fillRef idx="1">
+            <a:schemeClr val="accent1"/>
+          </a:fillRef>
+          <a:effectRef idx="0">
+            <a:schemeClr val="accent1"/>
+          </a:effectRef>
+          <a:fontRef idx="minor">
+            <a:schemeClr val="lt1"/>
+          </a:fontRef>
+        </p:style>
+        <p:txBody>
+          <a:bodyPr rtlCol="0" anchor="ctr"/>
+          <a:lstStyle/>
+          <a:p>
+            <a:pPr algn="ctr"/>
+            <a:endParaRPr lang="en-GB"/>
+          </a:p>
+        </p:txBody>
+      </p:sp>
+      <p:sp>
+        <p:nvSpPr>
+          <p:cNvPr id="9" name="TextBox 8">
+            <a:extLst>
+              <a:ext uri="{FF2B5EF4-FFF2-40B4-BE49-F238E27FC236}">
+                <a16:creationId xmlns:a16="http://schemas.microsoft.com/office/drawing/2014/main" id="{A49EB342-8F8C-AEAE-B40A-A55BA3E5E9EA}"/>
+              </a:ext>
+            </a:extLst>
+          </p:cNvPr>
+          <p:cNvSpPr txBox="1"/>
+          <p:nvPr/>
+        </p:nvSpPr>
+        <p:spPr>
+          <a:xfrm>
+            <a:off x="3132260" y="4311704"/>
+            <a:ext cx="962069" cy="369332"/>
+          </a:xfrm>
+          <a:prstGeom prst="rect">
+            <a:avLst/>
+          </a:prstGeom>
+          <a:noFill/>
+        </p:spPr>
+        <p:txBody>
+          <a:bodyPr wrap="square" rtlCol="0">
+            <a:spAutoFit/>
+          </a:bodyPr>
+          <a:lstStyle/>
+          <a:p>
+            <a:pPr algn="ctr"/>
+            <a:r>
+              <a:rPr lang="en-GB" dirty="0">
+                <a:solidFill>
+                  <a:srgbClr val="C00000"/>
+                </a:solidFill>
+              </a:rPr>
+              <a:t>Output</a:t>
+            </a:r>
+          </a:p>
+        </p:txBody>
+      </p:sp>
+      <p:sp>
+        <p:nvSpPr>
+          <p:cNvPr id="10" name="TextBox 9">
+            <a:extLst>
+              <a:ext uri="{FF2B5EF4-FFF2-40B4-BE49-F238E27FC236}">
+                <a16:creationId xmlns:a16="http://schemas.microsoft.com/office/drawing/2014/main" id="{967AD69A-9D53-A598-FF9B-8A73E4FF61E7}"/>
+              </a:ext>
+            </a:extLst>
+          </p:cNvPr>
+          <p:cNvSpPr txBox="1"/>
+          <p:nvPr/>
+        </p:nvSpPr>
+        <p:spPr>
+          <a:xfrm>
+            <a:off x="9186863" y="4586288"/>
+            <a:ext cx="1612150" cy="369332"/>
+          </a:xfrm>
+          <a:prstGeom prst="rect">
+            <a:avLst/>
+          </a:prstGeom>
+          <a:noFill/>
+        </p:spPr>
+        <p:txBody>
+          <a:bodyPr wrap="square" rtlCol="0">
+            <a:spAutoFit/>
+          </a:bodyPr>
+          <a:lstStyle/>
+          <a:p>
+            <a:pPr algn="ctr"/>
+            <a:r>
+              <a:rPr lang="en-GB" dirty="0">
+                <a:solidFill>
+                  <a:srgbClr val="C00000"/>
+                </a:solidFill>
+              </a:rPr>
+              <a:t>Error message</a:t>
+            </a:r>
+          </a:p>
+        </p:txBody>
+      </p:sp>
+    </p:spTree>
+    <p:extLst>
+      <p:ext uri="{BB962C8B-B14F-4D97-AF65-F5344CB8AC3E}">
+        <p14:creationId xmlns:p14="http://schemas.microsoft.com/office/powerpoint/2010/main" val="3767502288"/>
+      </p:ext>
+    </p:extLst>
+  </p:cSld>
+  <p:clrMapOvr>
+    <a:masterClrMapping/>
+  </p:clrMapOvr>
+</p:sld>
+</file>
+
+<file path=ppt/slides/slide6.xml><?xml version="1.0" encoding="utf-8"?>
+<p:sld xmlns:a="http://schemas.openxmlformats.org/drawingml/2006/main" xmlns:r="http://schemas.openxmlformats.org/officeDocument/2006/relationships" xmlns:p="http://schemas.openxmlformats.org/presentationml/2006/main">
+  <p:cSld>
+    <p:spTree>
+      <p:nvGrpSpPr>
+        <p:cNvPr id="1" name=""/>
+        <p:cNvGrpSpPr/>
+        <p:nvPr/>
+      </p:nvGrpSpPr>
+      <p:grpSpPr>
+        <a:xfrm>
+          <a:off x="0" y="0"/>
+          <a:ext cx="0" cy="0"/>
+          <a:chOff x="0" y="0"/>
+          <a:chExt cx="0" cy="0"/>
+        </a:xfrm>
+      </p:grpSpPr>
+      <p:pic>
+        <p:nvPicPr>
+          <p:cNvPr id="5" name="Picture 4">
+            <a:extLst>
+              <a:ext uri="{FF2B5EF4-FFF2-40B4-BE49-F238E27FC236}">
+                <a16:creationId xmlns:a16="http://schemas.microsoft.com/office/drawing/2014/main" id="{F30A9EA9-DECB-E096-E169-D050C1C41844}"/>
+              </a:ext>
+            </a:extLst>
+          </p:cNvPr>
+          <p:cNvPicPr>
+            <a:picLocks noChangeAspect="1"/>
+          </p:cNvPicPr>
+          <p:nvPr/>
+        </p:nvPicPr>
+        <p:blipFill>
+          <a:blip r:embed="rId2"/>
+          <a:stretch>
+            <a:fillRect/>
+          </a:stretch>
+        </p:blipFill>
+        <p:spPr>
+          <a:xfrm>
+            <a:off x="967884" y="0"/>
+            <a:ext cx="10256231" cy="6858000"/>
+          </a:xfrm>
+          <a:prstGeom prst="rect">
+            <a:avLst/>
+          </a:prstGeom>
+        </p:spPr>
+      </p:pic>
+    </p:spTree>
+    <p:extLst>
+      <p:ext uri="{BB962C8B-B14F-4D97-AF65-F5344CB8AC3E}">
+        <p14:creationId xmlns:p14="http://schemas.microsoft.com/office/powerpoint/2010/main" val="306873889"/>
+      </p:ext>
+    </p:extLst>
+  </p:cSld>
+  <p:clrMapOvr>
+    <a:masterClrMapping/>
+  </p:clrMapOvr>
+</p:sld>
+</file>
+
 <file path=ppt/theme/theme1.xml><?xml version="1.0" encoding="utf-8"?>
 <a:theme xmlns:a="http://schemas.openxmlformats.org/drawingml/2006/main" name="Office Theme">
   <a:themeElements>

</xml_diff>